<commit_message>
Acknowledge confirmed Allen feedback with team placeholders
</commit_message>
<xml_diff>
--- a/presentations/sdm-presentation2.pptx
+++ b/presentations/sdm-presentation2.pptx
@@ -2,25 +2,25 @@
 <file path=ppt/presentation.xml><?xml version="1.0" encoding="utf-8"?>
 <p:presentation xmlns:p="http://schemas.openxmlformats.org/presentationml/2006/main">
   <p:sldMasterIdLst>
-    <p:sldMasterId xmlns:r="http://schemas.openxmlformats.org/officeDocument/2006/relationships" id="2147483648" r:id="R6a8f10dea6b347b1"/>
+    <p:sldMasterId xmlns:r="http://schemas.openxmlformats.org/officeDocument/2006/relationships" id="2147483648" r:id="R6cf0ee3123424e62"/>
   </p:sldMasterIdLst>
   <p:notesMasterIdLst>
-    <p:notesMasterId xmlns:r="http://schemas.openxmlformats.org/officeDocument/2006/relationships" r:id="Rfebeadfee59d434b"/>
+    <p:notesMasterId xmlns:r="http://schemas.openxmlformats.org/officeDocument/2006/relationships" r:id="R53e4ec118ba94b7a"/>
   </p:notesMasterIdLst>
   <p:sldIdLst>
-    <p:sldId xmlns:r="http://schemas.openxmlformats.org/officeDocument/2006/relationships" id="256" r:id="R8be061edf25248ca"/>
-    <p:sldId xmlns:r="http://schemas.openxmlformats.org/officeDocument/2006/relationships" id="257" r:id="R476ce248765343c1"/>
-    <p:sldId xmlns:r="http://schemas.openxmlformats.org/officeDocument/2006/relationships" id="258" r:id="Reaee193187d344d8"/>
-    <p:sldId xmlns:r="http://schemas.openxmlformats.org/officeDocument/2006/relationships" id="259" r:id="Radb315dca02a4800"/>
-    <p:sldId xmlns:r="http://schemas.openxmlformats.org/officeDocument/2006/relationships" id="260" r:id="R6de53580c26b4c7b"/>
-    <p:sldId xmlns:r="http://schemas.openxmlformats.org/officeDocument/2006/relationships" id="261" r:id="Rb36840198f1849d8"/>
-    <p:sldId xmlns:r="http://schemas.openxmlformats.org/officeDocument/2006/relationships" id="262" r:id="R4484074bb2614045"/>
-    <p:sldId xmlns:r="http://schemas.openxmlformats.org/officeDocument/2006/relationships" id="263" r:id="R3bb5e0c68f524038"/>
-    <p:sldId xmlns:r="http://schemas.openxmlformats.org/officeDocument/2006/relationships" id="264" r:id="Rf2c04973f4424e41"/>
-    <p:sldId xmlns:r="http://schemas.openxmlformats.org/officeDocument/2006/relationships" id="265" r:id="R217abdd4d4cc485e"/>
-    <p:sldId xmlns:r="http://schemas.openxmlformats.org/officeDocument/2006/relationships" id="266" r:id="R54dff8d778f947f1"/>
-    <p:sldId xmlns:r="http://schemas.openxmlformats.org/officeDocument/2006/relationships" id="267" r:id="R323bd0c62e754709"/>
-    <p:sldId xmlns:r="http://schemas.openxmlformats.org/officeDocument/2006/relationships" id="268" r:id="Rc03491f6f97d4832"/>
+    <p:sldId xmlns:r="http://schemas.openxmlformats.org/officeDocument/2006/relationships" id="256" r:id="R6a8e00bf95764ba3"/>
+    <p:sldId xmlns:r="http://schemas.openxmlformats.org/officeDocument/2006/relationships" id="257" r:id="R4e8b037943c24326"/>
+    <p:sldId xmlns:r="http://schemas.openxmlformats.org/officeDocument/2006/relationships" id="258" r:id="R66d856c145fe42b9"/>
+    <p:sldId xmlns:r="http://schemas.openxmlformats.org/officeDocument/2006/relationships" id="259" r:id="R63bdaa633e204370"/>
+    <p:sldId xmlns:r="http://schemas.openxmlformats.org/officeDocument/2006/relationships" id="260" r:id="R00e902770a8643c7"/>
+    <p:sldId xmlns:r="http://schemas.openxmlformats.org/officeDocument/2006/relationships" id="261" r:id="Rf296038231324f2d"/>
+    <p:sldId xmlns:r="http://schemas.openxmlformats.org/officeDocument/2006/relationships" id="262" r:id="R5f5c54db425541cc"/>
+    <p:sldId xmlns:r="http://schemas.openxmlformats.org/officeDocument/2006/relationships" id="263" r:id="Rb2d2af09e534420f"/>
+    <p:sldId xmlns:r="http://schemas.openxmlformats.org/officeDocument/2006/relationships" id="264" r:id="R44b1f2d6d51d4571"/>
+    <p:sldId xmlns:r="http://schemas.openxmlformats.org/officeDocument/2006/relationships" id="265" r:id="R9fac6ce3eb0545b4"/>
+    <p:sldId xmlns:r="http://schemas.openxmlformats.org/officeDocument/2006/relationships" id="266" r:id="R42c2e9cb2c6c4aae"/>
+    <p:sldId xmlns:r="http://schemas.openxmlformats.org/officeDocument/2006/relationships" id="267" r:id="R2436f8d6bc9240d7"/>
+    <p:sldId xmlns:r="http://schemas.openxmlformats.org/officeDocument/2006/relationships" id="268" r:id="R8b7ad72509624e6d"/>
   </p:sldIdLst>
   <p:sldSz cx="12192000" cy="6858000"/>
   <p:notesSz cx="6858000" cy="9144000"/>
@@ -1004,7 +1004,7 @@
           </a:p>
           <a:p xmlns:a="http://schemas.openxmlformats.org/drawingml/2006/main">
             <a:r>
-              <a:t>Our deliverable is a research paper supported by reproducible experiments. It serves practitioners by answering two questions: what coverage is attainable at a chosen empirical reliability target, and whether SDM adds value beyond cheap raw-softmax and temperature-scaled baselines. We preserve the same checkpoint, label space and evaluation images within a comparison, record calibration support, and retain negative results. The supporting notebooks export configurations, identities, per-image decisions and aggregate metrics. The paper connects those outputs to accepted accuracy, coverage, probability calibration, error ranking, confusions and limitations. The project does not claim a production inspection product or a general safety guarantee. We considered several distinct confidence measurements because calibration quality, ranking quality and admission feasibility can disagree. A useful final contribution can be a carefully evidenced limitation of SDM transfer, not only a positive result. The full corrupted/OOD comparison remains unfinished, so today’s conclusion is deliberately restricted to completed clean tasks. The repository does not establish that the planned expert meeting occurred. Do not claim an interview, quote, or user validation unless the team confirms it. Questions for expert feedback include why a qualifying region can fail despite useful error ranking, and how to compare global empirical thresholds with SDM’s class-conditional construction.</a:t>
+              <a:t>Our deliverable is a research paper supported by reproducible experiments. It serves practitioners by answering two questions: what coverage is attainable at a chosen empirical reliability target, and whether SDM adds value beyond cheap raw-softmax and temperature-scaled baselines. We preserve the same checkpoint, label space and evaluation images within a comparison, record calibration support, and retain negative results. The supporting notebooks export configurations, identities, per-image decisions and aggregate metrics. The paper connects those outputs to accepted accuracy, coverage, probability calibration, error ranking, confusions and limitations. The project does not claim a production inspection product or a general safety guarantee. We considered several distinct confidence measurements because calibration quality, ranking quality and admission feasibility can disagree. A useful final contribution can be a carefully evidenced limitation of SDM transfer, not only a positive result. The full corrupted/OOD comparison remains unfinished, so today’s conclusion is deliberately restricted to completed clean tasks. Karim confirmed on October 29 that the team received feedback from Allen Schmaltz. The specific recommendations and changes made in response have not yet been supplied. Acknowledge the feedback without inventing a quote, meeting format, endorsement or validation outcome. Questions for expert feedback include why a qualifying region can fail despite useful error ranking, and how to compare global empirical thresholds with SDM’s class-conditional construction.</a:t>
             </a:r>
           </a:p>
           <a:p xmlns:a="http://schemas.openxmlformats.org/drawingml/2006/main">
@@ -1601,7 +1601,7 @@
           <p:cNvPr id="3" name="Title">
             <a:extLst xmlns:a="http://schemas.openxmlformats.org/drawingml/2006/main">
               <a:ext uri="{FF2B5EF4-FFF2-40B4-BE49-F238E27FC236}">
-                <a16:creationId xmlns:a16="http://schemas.microsoft.com/office/drawing/2014/main" id="{B5FFDE75-2514-48D1-9284-04BA34680202}"/>
+                <a16:creationId xmlns:a16="http://schemas.microsoft.com/office/drawing/2014/main" id="{F4B6FE93-7B49-4769-B6E7-E91859D8A69F}"/>
               </a:ext>
             </a:extLst>
           </p:cNvPr>
@@ -1830,7 +1830,7 @@
           <p:cNvPr id="2" name="Subtitle">
             <a:extLst xmlns:a="http://schemas.openxmlformats.org/drawingml/2006/main">
               <a:ext uri="{FF2B5EF4-FFF2-40B4-BE49-F238E27FC236}">
-                <a16:creationId xmlns:a16="http://schemas.microsoft.com/office/drawing/2014/main" id="{8181D848-4892-47F4-B156-533BA2A49D31}"/>
+                <a16:creationId xmlns:a16="http://schemas.microsoft.com/office/drawing/2014/main" id="{0E3FBA68-F60F-49C3-BAA1-2284C682F5BC}"/>
               </a:ext>
             </a:extLst>
           </p:cNvPr>
@@ -2076,7 +2076,7 @@
           <p:cNvPr id="2" name="Section title">
             <a:extLst xmlns:a="http://schemas.openxmlformats.org/drawingml/2006/main">
               <a:ext uri="{FF2B5EF4-FFF2-40B4-BE49-F238E27FC236}">
-                <a16:creationId xmlns:a16="http://schemas.microsoft.com/office/drawing/2014/main" id="{F1C7B7D5-25C0-4C95-80B3-D56992DDDC3D}"/>
+                <a16:creationId xmlns:a16="http://schemas.microsoft.com/office/drawing/2014/main" id="{93E1C1C4-943C-4D6A-AB6A-BD6997EBC908}"/>
               </a:ext>
             </a:extLst>
           </p:cNvPr>
@@ -2322,7 +2322,7 @@
           <p:cNvPr id="3" name="Title">
             <a:extLst xmlns:a="http://schemas.openxmlformats.org/drawingml/2006/main">
               <a:ext uri="{FF2B5EF4-FFF2-40B4-BE49-F238E27FC236}">
-                <a16:creationId xmlns:a16="http://schemas.microsoft.com/office/drawing/2014/main" id="{3FF43E4C-5AFC-4F1E-977D-6C9D60C6BF2D}"/>
+                <a16:creationId xmlns:a16="http://schemas.microsoft.com/office/drawing/2014/main" id="{382A7D91-BC1C-4E64-9524-E110A253E7CB}"/>
               </a:ext>
             </a:extLst>
           </p:cNvPr>
@@ -2551,7 +2551,7 @@
           <p:cNvPr id="2" name="Body">
             <a:extLst xmlns:a="http://schemas.openxmlformats.org/drawingml/2006/main">
               <a:ext uri="{FF2B5EF4-FFF2-40B4-BE49-F238E27FC236}">
-                <a16:creationId xmlns:a16="http://schemas.microsoft.com/office/drawing/2014/main" id="{ABB7B95C-65F7-4DCE-AB47-F75A35FE52CF}"/>
+                <a16:creationId xmlns:a16="http://schemas.microsoft.com/office/drawing/2014/main" id="{AE1B080C-EE55-48F5-86A5-A5766BAD7D0C}"/>
               </a:ext>
             </a:extLst>
           </p:cNvPr>
@@ -2797,7 +2797,7 @@
           <p:cNvPr id="4" name="Title">
             <a:extLst xmlns:a="http://schemas.openxmlformats.org/drawingml/2006/main">
               <a:ext uri="{FF2B5EF4-FFF2-40B4-BE49-F238E27FC236}">
-                <a16:creationId xmlns:a16="http://schemas.microsoft.com/office/drawing/2014/main" id="{3C6176DB-F181-4E19-8670-2A2C0952E251}"/>
+                <a16:creationId xmlns:a16="http://schemas.microsoft.com/office/drawing/2014/main" id="{844D7D52-95E8-41C8-BDD7-DCF939808875}"/>
               </a:ext>
             </a:extLst>
           </p:cNvPr>
@@ -3026,7 +3026,7 @@
           <p:cNvPr id="2" name="Left column">
             <a:extLst xmlns:a="http://schemas.openxmlformats.org/drawingml/2006/main">
               <a:ext uri="{FF2B5EF4-FFF2-40B4-BE49-F238E27FC236}">
-                <a16:creationId xmlns:a16="http://schemas.microsoft.com/office/drawing/2014/main" id="{B7894D8C-EC90-4E79-97D6-FF49691E068E}"/>
+                <a16:creationId xmlns:a16="http://schemas.microsoft.com/office/drawing/2014/main" id="{BAE8BB4F-9515-4402-85A7-EE2B72527A0F}"/>
               </a:ext>
             </a:extLst>
           </p:cNvPr>
@@ -3255,7 +3255,7 @@
           <p:cNvPr id="3" name="Right column">
             <a:extLst xmlns:a="http://schemas.openxmlformats.org/drawingml/2006/main">
               <a:ext uri="{FF2B5EF4-FFF2-40B4-BE49-F238E27FC236}">
-                <a16:creationId xmlns:a16="http://schemas.microsoft.com/office/drawing/2014/main" id="{64A58C6B-AACA-4695-9BBB-17BCE41CBD34}"/>
+                <a16:creationId xmlns:a16="http://schemas.microsoft.com/office/drawing/2014/main" id="{83408B66-C3DC-4DFC-A7ED-F48C58E5BA83}"/>
               </a:ext>
             </a:extLst>
           </p:cNvPr>
@@ -3501,7 +3501,7 @@
           <p:cNvPr id="3" name="Title">
             <a:extLst xmlns:a="http://schemas.openxmlformats.org/drawingml/2006/main">
               <a:ext uri="{FF2B5EF4-FFF2-40B4-BE49-F238E27FC236}">
-                <a16:creationId xmlns:a16="http://schemas.microsoft.com/office/drawing/2014/main" id="{2F879E54-E628-4F17-9632-FEBCF295405D}"/>
+                <a16:creationId xmlns:a16="http://schemas.microsoft.com/office/drawing/2014/main" id="{0542A56C-C61A-40CC-92CC-E7F856FF1976}"/>
               </a:ext>
             </a:extLst>
           </p:cNvPr>
@@ -3730,7 +3730,7 @@
           <p:cNvPr id="2" name="Left column">
             <a:extLst xmlns:a="http://schemas.openxmlformats.org/drawingml/2006/main">
               <a:ext uri="{FF2B5EF4-FFF2-40B4-BE49-F238E27FC236}">
-                <a16:creationId xmlns:a16="http://schemas.microsoft.com/office/drawing/2014/main" id="{7A4A7678-CE03-4310-AAF9-12EFC32E59BD}"/>
+                <a16:creationId xmlns:a16="http://schemas.microsoft.com/office/drawing/2014/main" id="{923F7862-F7BF-45BD-AD4F-741973D370CB}"/>
               </a:ext>
             </a:extLst>
           </p:cNvPr>
@@ -3997,12 +3997,12 @@
   </p:cSld>
   <p:clrMap bg1="lt1" tx1="dk1" bg2="lt2" tx2="dk2" accent1="accent1" accent2="accent2" accent3="accent3" accent4="accent4" accent5="accent5" accent6="accent6" hlink="hlink" folHlink="folHlink"/>
   <p:sldLayoutIdLst>
-    <p:sldLayoutId xmlns:r="http://schemas.openxmlformats.org/officeDocument/2006/relationships" id="2147483649" r:id="Rea94be7b83fe4b1f"/>
-    <p:sldLayoutId xmlns:r="http://schemas.openxmlformats.org/officeDocument/2006/relationships" id="2147483650" r:id="R6031d26f87784c07"/>
-    <p:sldLayoutId xmlns:r="http://schemas.openxmlformats.org/officeDocument/2006/relationships" id="2147483651" r:id="Rfeaa2511940747a4"/>
-    <p:sldLayoutId xmlns:r="http://schemas.openxmlformats.org/officeDocument/2006/relationships" id="2147483652" r:id="R1a160f63fe62478f"/>
-    <p:sldLayoutId xmlns:r="http://schemas.openxmlformats.org/officeDocument/2006/relationships" id="2147483653" r:id="Rd2aec82c516240bf"/>
-    <p:sldLayoutId xmlns:r="http://schemas.openxmlformats.org/officeDocument/2006/relationships" id="2147483654" r:id="Re80fd6acc5bc4e44"/>
+    <p:sldLayoutId xmlns:r="http://schemas.openxmlformats.org/officeDocument/2006/relationships" id="2147483649" r:id="R84d961fc141141bb"/>
+    <p:sldLayoutId xmlns:r="http://schemas.openxmlformats.org/officeDocument/2006/relationships" id="2147483650" r:id="Ref5e6658403c4cf9"/>
+    <p:sldLayoutId xmlns:r="http://schemas.openxmlformats.org/officeDocument/2006/relationships" id="2147483651" r:id="R80e1b104f07148f9"/>
+    <p:sldLayoutId xmlns:r="http://schemas.openxmlformats.org/officeDocument/2006/relationships" id="2147483652" r:id="R765e51c5309c4f72"/>
+    <p:sldLayoutId xmlns:r="http://schemas.openxmlformats.org/officeDocument/2006/relationships" id="2147483653" r:id="R7ca405798eb24abe"/>
+    <p:sldLayoutId xmlns:r="http://schemas.openxmlformats.org/officeDocument/2006/relationships" id="2147483654" r:id="Re1720a6033f84623"/>
   </p:sldLayoutIdLst>
   <p:txStyles>
     <p:titleStyle>
@@ -4816,7 +4816,7 @@
           <p:cNvPr id="6" name="">
             <a:extLst xmlns:a="http://schemas.openxmlformats.org/drawingml/2006/main">
               <a:ext uri="{FF2B5EF4-FFF2-40B4-BE49-F238E27FC236}">
-                <a16:creationId xmlns:a16="http://schemas.microsoft.com/office/drawing/2014/main" id="{EA1E0F26-C14B-48CC-8AF1-A8E41DA4BE5F}"/>
+                <a16:creationId xmlns:a16="http://schemas.microsoft.com/office/drawing/2014/main" id="{38F09C43-1218-4461-AAA2-143FF0EB421F}"/>
               </a:ext>
             </a:extLst>
           </p:cNvPr>
@@ -4846,7 +4846,7 @@
           <p:cNvPr id="2" name="">
             <a:extLst xmlns:a="http://schemas.openxmlformats.org/drawingml/2006/main">
               <a:ext uri="{FF2B5EF4-FFF2-40B4-BE49-F238E27FC236}">
-                <a16:creationId xmlns:a16="http://schemas.microsoft.com/office/drawing/2014/main" id="{90E18958-9011-4523-9D74-93F847C1A738}"/>
+                <a16:creationId xmlns:a16="http://schemas.microsoft.com/office/drawing/2014/main" id="{DF1209AC-39C3-43F7-9400-EA6E91DF09A4}"/>
               </a:ext>
             </a:extLst>
           </p:cNvPr>
@@ -4925,7 +4925,7 @@
           <p:cNvPr id="3" name="">
             <a:extLst xmlns:a="http://schemas.openxmlformats.org/drawingml/2006/main">
               <a:ext uri="{FF2B5EF4-FFF2-40B4-BE49-F238E27FC236}">
-                <a16:creationId xmlns:a16="http://schemas.microsoft.com/office/drawing/2014/main" id="{2647F892-3351-4C40-ABC9-D15DD6637900}"/>
+                <a16:creationId xmlns:a16="http://schemas.microsoft.com/office/drawing/2014/main" id="{0CDBEB65-DEB5-426E-8969-16A98C89B51C}"/>
               </a:ext>
             </a:extLst>
           </p:cNvPr>
@@ -5004,7 +5004,7 @@
           <p:cNvPr id="4" name="">
             <a:extLst xmlns:a="http://schemas.openxmlformats.org/drawingml/2006/main">
               <a:ext uri="{FF2B5EF4-FFF2-40B4-BE49-F238E27FC236}">
-                <a16:creationId xmlns:a16="http://schemas.microsoft.com/office/drawing/2014/main" id="{C8C98922-D3D7-42DD-92BB-D18E2D9771F2}"/>
+                <a16:creationId xmlns:a16="http://schemas.microsoft.com/office/drawing/2014/main" id="{84B46368-7D26-4BB5-907F-D4AB896239A2}"/>
               </a:ext>
             </a:extLst>
           </p:cNvPr>
@@ -5104,7 +5104,7 @@
           <p:cNvPr id="5" name="">
             <a:extLst xmlns:a="http://schemas.openxmlformats.org/drawingml/2006/main">
               <a:ext uri="{FF2B5EF4-FFF2-40B4-BE49-F238E27FC236}">
-                <a16:creationId xmlns:a16="http://schemas.microsoft.com/office/drawing/2014/main" id="{82AD7975-CAFD-4BE3-9767-68333EF1C4E4}"/>
+                <a16:creationId xmlns:a16="http://schemas.microsoft.com/office/drawing/2014/main" id="{424F5118-84F0-4E33-ACB3-28613A5F884A}"/>
               </a:ext>
             </a:extLst>
           </p:cNvPr>
@@ -5181,7 +5181,7 @@
     </p:spTree>
     <p:extLst>
       <p:ext uri="{BB962C8B-B14F-4D97-AF65-F5344CB8AC3E}">
-        <p14:creationId xmlns:p14="http://schemas.microsoft.com/office/powerpoint/2010/main" val="636195257"/>
+        <p14:creationId xmlns:p14="http://schemas.microsoft.com/office/powerpoint/2010/main" val="15336083"/>
       </p:ext>
     </p:extLst>
   </p:cSld>
@@ -5212,7 +5212,7 @@
           <p:cNvPr id="4" name="">
             <a:extLst xmlns:a="http://schemas.openxmlformats.org/drawingml/2006/main">
               <a:ext uri="{FF2B5EF4-FFF2-40B4-BE49-F238E27FC236}">
-                <a16:creationId xmlns:a16="http://schemas.microsoft.com/office/drawing/2014/main" id="{2B9D1C61-D6EB-41AD-B237-969C253403F9}"/>
+                <a16:creationId xmlns:a16="http://schemas.microsoft.com/office/drawing/2014/main" id="{676201A5-800A-4E31-A2B3-CA3853827642}"/>
               </a:ext>
             </a:extLst>
           </p:cNvPr>
@@ -5242,7 +5242,7 @@
           <p:cNvPr id="2" name="">
             <a:extLst xmlns:a="http://schemas.openxmlformats.org/drawingml/2006/main">
               <a:ext uri="{FF2B5EF4-FFF2-40B4-BE49-F238E27FC236}">
-                <a16:creationId xmlns:a16="http://schemas.microsoft.com/office/drawing/2014/main" id="{5EC3F72C-41E8-4932-9DB5-2D17B2111B06}"/>
+                <a16:creationId xmlns:a16="http://schemas.microsoft.com/office/drawing/2014/main" id="{6FCA4555-313D-4B9D-ADD4-D08CC2F6E68B}"/>
               </a:ext>
             </a:extLst>
           </p:cNvPr>
@@ -5321,7 +5321,7 @@
           <p:cNvPr id="3" name="">
             <a:extLst xmlns:a="http://schemas.openxmlformats.org/drawingml/2006/main">
               <a:ext uri="{FF2B5EF4-FFF2-40B4-BE49-F238E27FC236}">
-                <a16:creationId xmlns:a16="http://schemas.microsoft.com/office/drawing/2014/main" id="{85CB2801-2092-448B-93D6-A0B6FC3367EA}"/>
+                <a16:creationId xmlns:a16="http://schemas.microsoft.com/office/drawing/2014/main" id="{0BE54208-BF52-44E2-9E6C-1A3EA7DB1CEF}"/>
               </a:ext>
             </a:extLst>
           </p:cNvPr>
@@ -5331,7 +5331,7 @@
           <p:nvPr/>
         </p:nvPicPr>
         <p:blipFill>
-          <a:blip xmlns:r="http://schemas.openxmlformats.org/officeDocument/2006/relationships" xmlns:a="http://schemas.openxmlformats.org/drawingml/2006/main" r:embed="R9b62c9c8e26245df"/>
+          <a:blip xmlns:r="http://schemas.openxmlformats.org/officeDocument/2006/relationships" xmlns:a="http://schemas.openxmlformats.org/drawingml/2006/main" r:embed="R9d6d9be1e4044e98"/>
           <a:stretch xmlns:a="http://schemas.openxmlformats.org/drawingml/2006/main"/>
         </p:blipFill>
         <p:spPr>
@@ -5347,7 +5347,7 @@
     </p:spTree>
     <p:extLst>
       <p:ext uri="{BB962C8B-B14F-4D97-AF65-F5344CB8AC3E}">
-        <p14:creationId xmlns:p14="http://schemas.microsoft.com/office/powerpoint/2010/main" val="975101754"/>
+        <p14:creationId xmlns:p14="http://schemas.microsoft.com/office/powerpoint/2010/main" val="125539917"/>
       </p:ext>
     </p:extLst>
   </p:cSld>
@@ -5378,7 +5378,7 @@
           <p:cNvPr id="7" name="">
             <a:extLst xmlns:a="http://schemas.openxmlformats.org/drawingml/2006/main">
               <a:ext uri="{FF2B5EF4-FFF2-40B4-BE49-F238E27FC236}">
-                <a16:creationId xmlns:a16="http://schemas.microsoft.com/office/drawing/2014/main" id="{41CC66C4-9900-47CB-8568-1418162FD0A9}"/>
+                <a16:creationId xmlns:a16="http://schemas.microsoft.com/office/drawing/2014/main" id="{258177D3-C701-4A66-87AB-1F398B1F917B}"/>
               </a:ext>
             </a:extLst>
           </p:cNvPr>
@@ -5408,7 +5408,7 @@
           <p:cNvPr id="2" name="">
             <a:extLst xmlns:a="http://schemas.openxmlformats.org/drawingml/2006/main">
               <a:ext uri="{FF2B5EF4-FFF2-40B4-BE49-F238E27FC236}">
-                <a16:creationId xmlns:a16="http://schemas.microsoft.com/office/drawing/2014/main" id="{9D363121-41BC-4A6D-9C1D-7B5535B0F254}"/>
+                <a16:creationId xmlns:a16="http://schemas.microsoft.com/office/drawing/2014/main" id="{A8E1FAE1-284E-44B0-8F92-61C4963A8A54}"/>
               </a:ext>
             </a:extLst>
           </p:cNvPr>
@@ -5487,7 +5487,7 @@
           <p:cNvPr id="3" name="">
             <a:extLst xmlns:a="http://schemas.openxmlformats.org/drawingml/2006/main">
               <a:ext uri="{FF2B5EF4-FFF2-40B4-BE49-F238E27FC236}">
-                <a16:creationId xmlns:a16="http://schemas.microsoft.com/office/drawing/2014/main" id="{11BCEC07-1583-4282-A019-408D77F63E64}"/>
+                <a16:creationId xmlns:a16="http://schemas.microsoft.com/office/drawing/2014/main" id="{E097B4C6-A4BB-4BA5-ABF5-12603CAFE2B2}"/>
               </a:ext>
             </a:extLst>
           </p:cNvPr>
@@ -5566,7 +5566,7 @@
           <p:cNvPr id="4" name="">
             <a:extLst xmlns:a="http://schemas.openxmlformats.org/drawingml/2006/main">
               <a:ext uri="{FF2B5EF4-FFF2-40B4-BE49-F238E27FC236}">
-                <a16:creationId xmlns:a16="http://schemas.microsoft.com/office/drawing/2014/main" id="{3EE2EDFB-1C7A-427C-8466-DA11B48D744F}"/>
+                <a16:creationId xmlns:a16="http://schemas.microsoft.com/office/drawing/2014/main" id="{DEF98D0F-021A-4F9B-BF59-C04CD6DE6BA3}"/>
               </a:ext>
             </a:extLst>
           </p:cNvPr>
@@ -5708,7 +5708,7 @@
           <p:cNvPr id="5" name="">
             <a:extLst xmlns:a="http://schemas.openxmlformats.org/drawingml/2006/main">
               <a:ext uri="{FF2B5EF4-FFF2-40B4-BE49-F238E27FC236}">
-                <a16:creationId xmlns:a16="http://schemas.microsoft.com/office/drawing/2014/main" id="{AD09FC0C-B0B3-4652-AF85-235E4CFC930A}"/>
+                <a16:creationId xmlns:a16="http://schemas.microsoft.com/office/drawing/2014/main" id="{55565158-671D-43AC-A4BF-95FE2D48712C}"/>
               </a:ext>
             </a:extLst>
           </p:cNvPr>
@@ -5787,7 +5787,7 @@
           <p:cNvPr id="6" name="">
             <a:extLst xmlns:a="http://schemas.openxmlformats.org/drawingml/2006/main">
               <a:ext uri="{FF2B5EF4-FFF2-40B4-BE49-F238E27FC236}">
-                <a16:creationId xmlns:a16="http://schemas.microsoft.com/office/drawing/2014/main" id="{A23C86DD-3B24-4C17-A1DF-19591C2F8348}"/>
+                <a16:creationId xmlns:a16="http://schemas.microsoft.com/office/drawing/2014/main" id="{A68B29E5-4BA9-40F9-B576-F7D2E48AA344}"/>
               </a:ext>
             </a:extLst>
           </p:cNvPr>
@@ -5927,7 +5927,7 @@
     </p:spTree>
     <p:extLst>
       <p:ext uri="{BB962C8B-B14F-4D97-AF65-F5344CB8AC3E}">
-        <p14:creationId xmlns:p14="http://schemas.microsoft.com/office/powerpoint/2010/main" val="177883222"/>
+        <p14:creationId xmlns:p14="http://schemas.microsoft.com/office/powerpoint/2010/main" val="805023845"/>
       </p:ext>
     </p:extLst>
   </p:cSld>
@@ -5958,7 +5958,7 @@
           <p:cNvPr id="5" name="">
             <a:extLst xmlns:a="http://schemas.openxmlformats.org/drawingml/2006/main">
               <a:ext uri="{FF2B5EF4-FFF2-40B4-BE49-F238E27FC236}">
-                <a16:creationId xmlns:a16="http://schemas.microsoft.com/office/drawing/2014/main" id="{F130BC3F-B36E-4746-BBD7-6A8DE6C9E7A2}"/>
+                <a16:creationId xmlns:a16="http://schemas.microsoft.com/office/drawing/2014/main" id="{D5434F88-568F-4FE8-8EC9-55B405C6A01C}"/>
               </a:ext>
             </a:extLst>
           </p:cNvPr>
@@ -5988,7 +5988,7 @@
           <p:cNvPr id="2" name="">
             <a:extLst xmlns:a="http://schemas.openxmlformats.org/drawingml/2006/main">
               <a:ext uri="{FF2B5EF4-FFF2-40B4-BE49-F238E27FC236}">
-                <a16:creationId xmlns:a16="http://schemas.microsoft.com/office/drawing/2014/main" id="{161A5B3C-8A2B-4F90-8B96-4DC3E8B1307E}"/>
+                <a16:creationId xmlns:a16="http://schemas.microsoft.com/office/drawing/2014/main" id="{DD457563-8379-4387-92AB-345A57349A6E}"/>
               </a:ext>
             </a:extLst>
           </p:cNvPr>
@@ -6067,7 +6067,7 @@
           <p:cNvPr id="3" name="">
             <a:extLst xmlns:a="http://schemas.openxmlformats.org/drawingml/2006/main">
               <a:ext uri="{FF2B5EF4-FFF2-40B4-BE49-F238E27FC236}">
-                <a16:creationId xmlns:a16="http://schemas.microsoft.com/office/drawing/2014/main" id="{01C918BE-41A7-4B04-B50B-CFBD9A268293}"/>
+                <a16:creationId xmlns:a16="http://schemas.microsoft.com/office/drawing/2014/main" id="{BDF959EA-09B2-451C-9B69-8BEFD744F77A}"/>
               </a:ext>
             </a:extLst>
           </p:cNvPr>
@@ -6578,7 +6578,7 @@
           <p:cNvPr id="4" name="">
             <a:extLst xmlns:a="http://schemas.openxmlformats.org/drawingml/2006/main">
               <a:ext uri="{FF2B5EF4-FFF2-40B4-BE49-F238E27FC236}">
-                <a16:creationId xmlns:a16="http://schemas.microsoft.com/office/drawing/2014/main" id="{5573078F-D884-4EC3-98A4-D104104873BA}"/>
+                <a16:creationId xmlns:a16="http://schemas.microsoft.com/office/drawing/2014/main" id="{45D1E1C5-C0EF-44B9-9648-62F57CCEAE18}"/>
               </a:ext>
             </a:extLst>
           </p:cNvPr>
@@ -6655,7 +6655,7 @@
     </p:spTree>
     <p:extLst>
       <p:ext uri="{BB962C8B-B14F-4D97-AF65-F5344CB8AC3E}">
-        <p14:creationId xmlns:p14="http://schemas.microsoft.com/office/powerpoint/2010/main" val="1451842114"/>
+        <p14:creationId xmlns:p14="http://schemas.microsoft.com/office/powerpoint/2010/main" val="1724953831"/>
       </p:ext>
     </p:extLst>
   </p:cSld>
@@ -6686,7 +6686,7 @@
           <p:cNvPr id="5" name="">
             <a:extLst xmlns:a="http://schemas.openxmlformats.org/drawingml/2006/main">
               <a:ext uri="{FF2B5EF4-FFF2-40B4-BE49-F238E27FC236}">
-                <a16:creationId xmlns:a16="http://schemas.microsoft.com/office/drawing/2014/main" id="{E7B443B1-E3E3-4AA4-808E-F3FC3E058B86}"/>
+                <a16:creationId xmlns:a16="http://schemas.microsoft.com/office/drawing/2014/main" id="{5F71364E-E952-4928-90F8-162B78BE66B2}"/>
               </a:ext>
             </a:extLst>
           </p:cNvPr>
@@ -6716,7 +6716,7 @@
           <p:cNvPr id="2" name="">
             <a:extLst xmlns:a="http://schemas.openxmlformats.org/drawingml/2006/main">
               <a:ext uri="{FF2B5EF4-FFF2-40B4-BE49-F238E27FC236}">
-                <a16:creationId xmlns:a16="http://schemas.microsoft.com/office/drawing/2014/main" id="{DAE446E3-0C44-4A19-87AA-54C53FCF0B35}"/>
+                <a16:creationId xmlns:a16="http://schemas.microsoft.com/office/drawing/2014/main" id="{58E1FE77-6390-4017-9988-2A5F137B0E56}"/>
               </a:ext>
             </a:extLst>
           </p:cNvPr>
@@ -6795,7 +6795,7 @@
           <p:cNvPr id="3" name="">
             <a:extLst xmlns:a="http://schemas.openxmlformats.org/drawingml/2006/main">
               <a:ext uri="{FF2B5EF4-FFF2-40B4-BE49-F238E27FC236}">
-                <a16:creationId xmlns:a16="http://schemas.microsoft.com/office/drawing/2014/main" id="{6E5D7AAB-9F56-4327-871F-1D2670790E98}"/>
+                <a16:creationId xmlns:a16="http://schemas.microsoft.com/office/drawing/2014/main" id="{E62BCE14-E337-462B-A793-510983A3C52A}"/>
               </a:ext>
             </a:extLst>
           </p:cNvPr>
@@ -6874,7 +6874,7 @@
           <p:cNvPr id="4" name="">
             <a:extLst xmlns:a="http://schemas.openxmlformats.org/drawingml/2006/main">
               <a:ext uri="{FF2B5EF4-FFF2-40B4-BE49-F238E27FC236}">
-                <a16:creationId xmlns:a16="http://schemas.microsoft.com/office/drawing/2014/main" id="{9FBC6E0D-AFB1-47B8-9A3F-524EB597F7B8}"/>
+                <a16:creationId xmlns:a16="http://schemas.microsoft.com/office/drawing/2014/main" id="{A5032BA3-E365-48A1-AF7C-724F3E0BFBF2}"/>
               </a:ext>
             </a:extLst>
           </p:cNvPr>
@@ -6951,7 +6951,7 @@
     </p:spTree>
     <p:extLst>
       <p:ext uri="{BB962C8B-B14F-4D97-AF65-F5344CB8AC3E}">
-        <p14:creationId xmlns:p14="http://schemas.microsoft.com/office/powerpoint/2010/main" val="164636144"/>
+        <p14:creationId xmlns:p14="http://schemas.microsoft.com/office/powerpoint/2010/main" val="1105777305"/>
       </p:ext>
     </p:extLst>
   </p:cSld>
@@ -6982,7 +6982,7 @@
           <p:cNvPr id="8" name="">
             <a:extLst xmlns:a="http://schemas.openxmlformats.org/drawingml/2006/main">
               <a:ext uri="{FF2B5EF4-FFF2-40B4-BE49-F238E27FC236}">
-                <a16:creationId xmlns:a16="http://schemas.microsoft.com/office/drawing/2014/main" id="{6DD5940F-5B81-40AB-8EC6-13743396D8C9}"/>
+                <a16:creationId xmlns:a16="http://schemas.microsoft.com/office/drawing/2014/main" id="{C594B952-3078-4E75-BAB9-2A65870A3BB8}"/>
               </a:ext>
             </a:extLst>
           </p:cNvPr>
@@ -7012,7 +7012,7 @@
           <p:cNvPr id="2" name="">
             <a:extLst xmlns:a="http://schemas.openxmlformats.org/drawingml/2006/main">
               <a:ext uri="{FF2B5EF4-FFF2-40B4-BE49-F238E27FC236}">
-                <a16:creationId xmlns:a16="http://schemas.microsoft.com/office/drawing/2014/main" id="{5E633E11-45C9-4C27-A3FE-E504FE7952E4}"/>
+                <a16:creationId xmlns:a16="http://schemas.microsoft.com/office/drawing/2014/main" id="{FB826988-D9BA-42D8-BC01-D5EC51D0850E}"/>
               </a:ext>
             </a:extLst>
           </p:cNvPr>
@@ -7091,7 +7091,7 @@
           <p:cNvPr id="3" name="">
             <a:extLst xmlns:a="http://schemas.openxmlformats.org/drawingml/2006/main">
               <a:ext uri="{FF2B5EF4-FFF2-40B4-BE49-F238E27FC236}">
-                <a16:creationId xmlns:a16="http://schemas.microsoft.com/office/drawing/2014/main" id="{33ECEFBC-674B-46B2-B488-687F506CE8B4}"/>
+                <a16:creationId xmlns:a16="http://schemas.microsoft.com/office/drawing/2014/main" id="{7C701CD2-6A7A-4CEC-8FF9-317CC0C83506}"/>
               </a:ext>
             </a:extLst>
           </p:cNvPr>
@@ -7170,7 +7170,7 @@
           <p:cNvPr id="4" name="">
             <a:extLst xmlns:a="http://schemas.openxmlformats.org/drawingml/2006/main">
               <a:ext uri="{FF2B5EF4-FFF2-40B4-BE49-F238E27FC236}">
-                <a16:creationId xmlns:a16="http://schemas.microsoft.com/office/drawing/2014/main" id="{ECDED324-D7B4-419E-B4D5-E11C3EB8DA8A}"/>
+                <a16:creationId xmlns:a16="http://schemas.microsoft.com/office/drawing/2014/main" id="{59360969-BC2A-4B46-9692-5694C4538F09}"/>
               </a:ext>
             </a:extLst>
           </p:cNvPr>
@@ -7249,7 +7249,7 @@
           <p:cNvPr id="5" name="">
             <a:extLst xmlns:a="http://schemas.openxmlformats.org/drawingml/2006/main">
               <a:ext uri="{FF2B5EF4-FFF2-40B4-BE49-F238E27FC236}">
-                <a16:creationId xmlns:a16="http://schemas.microsoft.com/office/drawing/2014/main" id="{ABCD6EA4-2816-473E-9DAC-C77BAE3EF363}"/>
+                <a16:creationId xmlns:a16="http://schemas.microsoft.com/office/drawing/2014/main" id="{5F77C428-3B9F-4A44-88AB-1CED0B5CC005}"/>
               </a:ext>
             </a:extLst>
           </p:cNvPr>
@@ -7328,7 +7328,7 @@
           <p:cNvPr id="6" name="">
             <a:extLst xmlns:a="http://schemas.openxmlformats.org/drawingml/2006/main">
               <a:ext uri="{FF2B5EF4-FFF2-40B4-BE49-F238E27FC236}">
-                <a16:creationId xmlns:a16="http://schemas.microsoft.com/office/drawing/2014/main" id="{F39F839F-6068-46DC-98AB-CB793587FD11}"/>
+                <a16:creationId xmlns:a16="http://schemas.microsoft.com/office/drawing/2014/main" id="{D2F80D3F-7013-4612-8E33-CE9C620E2831}"/>
               </a:ext>
             </a:extLst>
           </p:cNvPr>
@@ -7407,7 +7407,7 @@
           <p:cNvPr id="7" name="">
             <a:extLst xmlns:a="http://schemas.openxmlformats.org/drawingml/2006/main">
               <a:ext uri="{FF2B5EF4-FFF2-40B4-BE49-F238E27FC236}">
-                <a16:creationId xmlns:a16="http://schemas.microsoft.com/office/drawing/2014/main" id="{66207E30-A78D-41AF-8C6D-58729B22EF2E}"/>
+                <a16:creationId xmlns:a16="http://schemas.microsoft.com/office/drawing/2014/main" id="{9CFB3616-70CF-493F-98B4-03FE1C61EF40}"/>
               </a:ext>
             </a:extLst>
           </p:cNvPr>
@@ -7484,7 +7484,7 @@
     </p:spTree>
     <p:extLst>
       <p:ext uri="{BB962C8B-B14F-4D97-AF65-F5344CB8AC3E}">
-        <p14:creationId xmlns:p14="http://schemas.microsoft.com/office/powerpoint/2010/main" val="10847421"/>
+        <p14:creationId xmlns:p14="http://schemas.microsoft.com/office/powerpoint/2010/main" val="172652920"/>
       </p:ext>
     </p:extLst>
   </p:cSld>
@@ -7515,7 +7515,7 @@
           <p:cNvPr id="8" name="">
             <a:extLst xmlns:a="http://schemas.openxmlformats.org/drawingml/2006/main">
               <a:ext uri="{FF2B5EF4-FFF2-40B4-BE49-F238E27FC236}">
-                <a16:creationId xmlns:a16="http://schemas.microsoft.com/office/drawing/2014/main" id="{89A2EE79-88BA-40A9-8197-35A047EE62E4}"/>
+                <a16:creationId xmlns:a16="http://schemas.microsoft.com/office/drawing/2014/main" id="{C0BEF3DF-7929-45C7-94EE-0F772A085990}"/>
               </a:ext>
             </a:extLst>
           </p:cNvPr>
@@ -7545,7 +7545,7 @@
           <p:cNvPr id="2" name="">
             <a:extLst xmlns:a="http://schemas.openxmlformats.org/drawingml/2006/main">
               <a:ext uri="{FF2B5EF4-FFF2-40B4-BE49-F238E27FC236}">
-                <a16:creationId xmlns:a16="http://schemas.microsoft.com/office/drawing/2014/main" id="{3A166D46-AE84-4D19-8D4C-997202E7E227}"/>
+                <a16:creationId xmlns:a16="http://schemas.microsoft.com/office/drawing/2014/main" id="{415EBE0E-4BBC-4D5C-9DDE-2E54492C53F4}"/>
               </a:ext>
             </a:extLst>
           </p:cNvPr>
@@ -7624,7 +7624,7 @@
           <p:cNvPr id="3" name="">
             <a:extLst xmlns:a="http://schemas.openxmlformats.org/drawingml/2006/main">
               <a:ext uri="{FF2B5EF4-FFF2-40B4-BE49-F238E27FC236}">
-                <a16:creationId xmlns:a16="http://schemas.microsoft.com/office/drawing/2014/main" id="{267A692D-30D0-4AAD-AF17-AF118188354C}"/>
+                <a16:creationId xmlns:a16="http://schemas.microsoft.com/office/drawing/2014/main" id="{E8B9AF8C-E7E2-4455-A231-A3B912D8B7A9}"/>
               </a:ext>
             </a:extLst>
           </p:cNvPr>
@@ -7703,7 +7703,7 @@
           <p:cNvPr id="4" name="">
             <a:extLst xmlns:a="http://schemas.openxmlformats.org/drawingml/2006/main">
               <a:ext uri="{FF2B5EF4-FFF2-40B4-BE49-F238E27FC236}">
-                <a16:creationId xmlns:a16="http://schemas.microsoft.com/office/drawing/2014/main" id="{AA2A0474-33F0-4A10-B3E0-E84751F2234D}"/>
+                <a16:creationId xmlns:a16="http://schemas.microsoft.com/office/drawing/2014/main" id="{19D13DAF-A87C-4100-980E-4EC375BB387A}"/>
               </a:ext>
             </a:extLst>
           </p:cNvPr>
@@ -7845,7 +7845,7 @@
           <p:cNvPr id="5" name="">
             <a:extLst xmlns:a="http://schemas.openxmlformats.org/drawingml/2006/main">
               <a:ext uri="{FF2B5EF4-FFF2-40B4-BE49-F238E27FC236}">
-                <a16:creationId xmlns:a16="http://schemas.microsoft.com/office/drawing/2014/main" id="{7FB103AE-2B4E-43D3-9EAE-D293E679F9FE}"/>
+                <a16:creationId xmlns:a16="http://schemas.microsoft.com/office/drawing/2014/main" id="{73C36A6A-D08E-4645-8F10-CE7CAC7373B6}"/>
               </a:ext>
             </a:extLst>
           </p:cNvPr>
@@ -7924,7 +7924,7 @@
           <p:cNvPr id="6" name="">
             <a:extLst xmlns:a="http://schemas.openxmlformats.org/drawingml/2006/main">
               <a:ext uri="{FF2B5EF4-FFF2-40B4-BE49-F238E27FC236}">
-                <a16:creationId xmlns:a16="http://schemas.microsoft.com/office/drawing/2014/main" id="{4BAD2D09-3927-4A48-8429-A95CBF282DD9}"/>
+                <a16:creationId xmlns:a16="http://schemas.microsoft.com/office/drawing/2014/main" id="{BA912DD6-FC4F-42AF-AE61-52D08AC24158}"/>
               </a:ext>
             </a:extLst>
           </p:cNvPr>
@@ -8034,7 +8034,7 @@
           <p:cNvPr id="7" name="">
             <a:extLst xmlns:a="http://schemas.openxmlformats.org/drawingml/2006/main">
               <a:ext uri="{FF2B5EF4-FFF2-40B4-BE49-F238E27FC236}">
-                <a16:creationId xmlns:a16="http://schemas.microsoft.com/office/drawing/2014/main" id="{0759110A-8EBB-4872-A6C5-924A962746D4}"/>
+                <a16:creationId xmlns:a16="http://schemas.microsoft.com/office/drawing/2014/main" id="{37835DF5-0713-4E68-B398-6E8F176ECB67}"/>
               </a:ext>
             </a:extLst>
           </p:cNvPr>
@@ -8103,7 +8103,7 @@
                 <a:ea typeface="Arial"/>
                 <a:cs typeface="Arial"/>
               </a:rPr>
-              <a:t>Practitioner and expert validation remains a task unless the team confirms completed feedback.</a:t>
+              <a:t>Allen Schmaltz feedback: [add key advice and resulting changes].</a:t>
             </a:r>
           </a:p>
         </p:txBody>
@@ -8111,7 +8111,7 @@
     </p:spTree>
     <p:extLst>
       <p:ext uri="{BB962C8B-B14F-4D97-AF65-F5344CB8AC3E}">
-        <p14:creationId xmlns:p14="http://schemas.microsoft.com/office/powerpoint/2010/main" val="178323389"/>
+        <p14:creationId xmlns:p14="http://schemas.microsoft.com/office/powerpoint/2010/main" val="5756455"/>
       </p:ext>
     </p:extLst>
   </p:cSld>
@@ -8142,7 +8142,7 @@
           <p:cNvPr id="10" name="">
             <a:extLst xmlns:a="http://schemas.openxmlformats.org/drawingml/2006/main">
               <a:ext uri="{FF2B5EF4-FFF2-40B4-BE49-F238E27FC236}">
-                <a16:creationId xmlns:a16="http://schemas.microsoft.com/office/drawing/2014/main" id="{3C4E47D5-883C-4F48-87FF-0BAF21F4459E}"/>
+                <a16:creationId xmlns:a16="http://schemas.microsoft.com/office/drawing/2014/main" id="{A3016C73-4F4B-461F-BB2D-59EE2308EF87}"/>
               </a:ext>
             </a:extLst>
           </p:cNvPr>
@@ -8172,7 +8172,7 @@
           <p:cNvPr id="2" name="">
             <a:extLst xmlns:a="http://schemas.openxmlformats.org/drawingml/2006/main">
               <a:ext uri="{FF2B5EF4-FFF2-40B4-BE49-F238E27FC236}">
-                <a16:creationId xmlns:a16="http://schemas.microsoft.com/office/drawing/2014/main" id="{0B57C93A-9DA9-4D23-9868-604C54C5BAF8}"/>
+                <a16:creationId xmlns:a16="http://schemas.microsoft.com/office/drawing/2014/main" id="{C5B36BF2-65CF-4CDC-972B-A7EA4C78DE90}"/>
               </a:ext>
             </a:extLst>
           </p:cNvPr>
@@ -8251,7 +8251,7 @@
           <p:cNvPr id="3" name="">
             <a:extLst xmlns:a="http://schemas.openxmlformats.org/drawingml/2006/main">
               <a:ext uri="{FF2B5EF4-FFF2-40B4-BE49-F238E27FC236}">
-                <a16:creationId xmlns:a16="http://schemas.microsoft.com/office/drawing/2014/main" id="{6C63FDD0-5B4F-427F-90ED-B897E8509486}"/>
+                <a16:creationId xmlns:a16="http://schemas.microsoft.com/office/drawing/2014/main" id="{9CE2AA72-F2CA-4D52-9AE9-2D74D62DB488}"/>
               </a:ext>
             </a:extLst>
           </p:cNvPr>
@@ -8330,7 +8330,7 @@
           <p:cNvPr id="4" name="">
             <a:extLst xmlns:a="http://schemas.openxmlformats.org/drawingml/2006/main">
               <a:ext uri="{FF2B5EF4-FFF2-40B4-BE49-F238E27FC236}">
-                <a16:creationId xmlns:a16="http://schemas.microsoft.com/office/drawing/2014/main" id="{30CE266F-F453-4FC4-8CAE-31B61FE39A93}"/>
+                <a16:creationId xmlns:a16="http://schemas.microsoft.com/office/drawing/2014/main" id="{D90394A1-7A34-445E-8E67-4BB0A0F4866E}"/>
               </a:ext>
             </a:extLst>
           </p:cNvPr>
@@ -8409,7 +8409,7 @@
           <p:cNvPr id="5" name="">
             <a:extLst xmlns:a="http://schemas.openxmlformats.org/drawingml/2006/main">
               <a:ext uri="{FF2B5EF4-FFF2-40B4-BE49-F238E27FC236}">
-                <a16:creationId xmlns:a16="http://schemas.microsoft.com/office/drawing/2014/main" id="{B90DD38F-1AEE-4703-A746-034A0970FD90}"/>
+                <a16:creationId xmlns:a16="http://schemas.microsoft.com/office/drawing/2014/main" id="{E33BE715-FCF5-42B8-A1CA-1DD3885E4580}"/>
               </a:ext>
             </a:extLst>
           </p:cNvPr>
@@ -8488,7 +8488,7 @@
           <p:cNvPr id="6" name="">
             <a:extLst xmlns:a="http://schemas.openxmlformats.org/drawingml/2006/main">
               <a:ext uri="{FF2B5EF4-FFF2-40B4-BE49-F238E27FC236}">
-                <a16:creationId xmlns:a16="http://schemas.microsoft.com/office/drawing/2014/main" id="{D32C741F-82D5-448B-8C29-3B6EC6E84369}"/>
+                <a16:creationId xmlns:a16="http://schemas.microsoft.com/office/drawing/2014/main" id="{3D69D84F-96D3-4E94-9B64-DE4FBFB5CE8E}"/>
               </a:ext>
             </a:extLst>
           </p:cNvPr>
@@ -8567,7 +8567,7 @@
           <p:cNvPr id="7" name="">
             <a:extLst xmlns:a="http://schemas.openxmlformats.org/drawingml/2006/main">
               <a:ext uri="{FF2B5EF4-FFF2-40B4-BE49-F238E27FC236}">
-                <a16:creationId xmlns:a16="http://schemas.microsoft.com/office/drawing/2014/main" id="{4323CD61-1B69-4A9F-8C85-8BD20BF4C648}"/>
+                <a16:creationId xmlns:a16="http://schemas.microsoft.com/office/drawing/2014/main" id="{C0AADCBF-0659-4A74-8528-5E4D77098697}"/>
               </a:ext>
             </a:extLst>
           </p:cNvPr>
@@ -8646,7 +8646,7 @@
           <p:cNvPr id="8" name="">
             <a:extLst xmlns:a="http://schemas.openxmlformats.org/drawingml/2006/main">
               <a:ext uri="{FF2B5EF4-FFF2-40B4-BE49-F238E27FC236}">
-                <a16:creationId xmlns:a16="http://schemas.microsoft.com/office/drawing/2014/main" id="{A6B37B66-78A9-4DCE-9131-12688CF18D56}"/>
+                <a16:creationId xmlns:a16="http://schemas.microsoft.com/office/drawing/2014/main" id="{D21E7DFB-EFFC-4AD0-B65D-2301BCAFB8B5}"/>
               </a:ext>
             </a:extLst>
           </p:cNvPr>
@@ -8725,7 +8725,7 @@
           <p:cNvPr id="9" name="">
             <a:extLst xmlns:a="http://schemas.openxmlformats.org/drawingml/2006/main">
               <a:ext uri="{FF2B5EF4-FFF2-40B4-BE49-F238E27FC236}">
-                <a16:creationId xmlns:a16="http://schemas.microsoft.com/office/drawing/2014/main" id="{7AB26CED-1DAB-4AD1-9232-1F4E6546D7DA}"/>
+                <a16:creationId xmlns:a16="http://schemas.microsoft.com/office/drawing/2014/main" id="{166FC717-4871-45C3-8A1A-58D5DDA6F924}"/>
               </a:ext>
             </a:extLst>
           </p:cNvPr>
@@ -8802,7 +8802,7 @@
     </p:spTree>
     <p:extLst>
       <p:ext uri="{BB962C8B-B14F-4D97-AF65-F5344CB8AC3E}">
-        <p14:creationId xmlns:p14="http://schemas.microsoft.com/office/powerpoint/2010/main" val="221393678"/>
+        <p14:creationId xmlns:p14="http://schemas.microsoft.com/office/powerpoint/2010/main" val="1031647342"/>
       </p:ext>
     </p:extLst>
   </p:cSld>
@@ -8833,7 +8833,7 @@
           <p:cNvPr id="17" name="">
             <a:extLst xmlns:a="http://schemas.openxmlformats.org/drawingml/2006/main">
               <a:ext uri="{FF2B5EF4-FFF2-40B4-BE49-F238E27FC236}">
-                <a16:creationId xmlns:a16="http://schemas.microsoft.com/office/drawing/2014/main" id="{151E8582-F53C-4790-A724-681DBBCE458D}"/>
+                <a16:creationId xmlns:a16="http://schemas.microsoft.com/office/drawing/2014/main" id="{B034F1B2-C590-4576-8199-8B5284883992}"/>
               </a:ext>
             </a:extLst>
           </p:cNvPr>
@@ -8863,7 +8863,7 @@
           <p:cNvPr id="2" name="">
             <a:extLst xmlns:a="http://schemas.openxmlformats.org/drawingml/2006/main">
               <a:ext uri="{FF2B5EF4-FFF2-40B4-BE49-F238E27FC236}">
-                <a16:creationId xmlns:a16="http://schemas.microsoft.com/office/drawing/2014/main" id="{96591CBD-252A-4552-9355-E0BD1552BA8E}"/>
+                <a16:creationId xmlns:a16="http://schemas.microsoft.com/office/drawing/2014/main" id="{33041649-B291-440D-8CCD-FCCCDD3A9966}"/>
               </a:ext>
             </a:extLst>
           </p:cNvPr>
@@ -8942,7 +8942,7 @@
           <p:cNvPr id="3" name="">
             <a:extLst xmlns:a="http://schemas.openxmlformats.org/drawingml/2006/main">
               <a:ext uri="{FF2B5EF4-FFF2-40B4-BE49-F238E27FC236}">
-                <a16:creationId xmlns:a16="http://schemas.microsoft.com/office/drawing/2014/main" id="{3DD8A147-C867-4263-ADE4-22D05648FAF7}"/>
+                <a16:creationId xmlns:a16="http://schemas.microsoft.com/office/drawing/2014/main" id="{6F1BCFD5-BCDC-4E74-A222-DC7C90EC2A80}"/>
               </a:ext>
             </a:extLst>
           </p:cNvPr>
@@ -9021,7 +9021,7 @@
           <p:cNvPr id="4" name="">
             <a:extLst xmlns:a="http://schemas.openxmlformats.org/drawingml/2006/main">
               <a:ext uri="{FF2B5EF4-FFF2-40B4-BE49-F238E27FC236}">
-                <a16:creationId xmlns:a16="http://schemas.microsoft.com/office/drawing/2014/main" id="{212C4AC0-7F0E-41A7-9D72-A1350118AB2B}"/>
+                <a16:creationId xmlns:a16="http://schemas.microsoft.com/office/drawing/2014/main" id="{DE8EE4CF-6432-443B-BB7E-0B516EAC15B3}"/>
               </a:ext>
             </a:extLst>
           </p:cNvPr>
@@ -9100,7 +9100,7 @@
           <p:cNvPr id="5" name="">
             <a:extLst xmlns:a="http://schemas.openxmlformats.org/drawingml/2006/main">
               <a:ext uri="{FF2B5EF4-FFF2-40B4-BE49-F238E27FC236}">
-                <a16:creationId xmlns:a16="http://schemas.microsoft.com/office/drawing/2014/main" id="{0EA0892C-06A1-4428-A6BF-CA33A3D62BA2}"/>
+                <a16:creationId xmlns:a16="http://schemas.microsoft.com/office/drawing/2014/main" id="{7DF691FA-F6EB-4162-BB71-72B0784B5779}"/>
               </a:ext>
             </a:extLst>
           </p:cNvPr>
@@ -9179,7 +9179,7 @@
           <p:cNvPr id="6" name="">
             <a:extLst xmlns:a="http://schemas.openxmlformats.org/drawingml/2006/main">
               <a:ext uri="{FF2B5EF4-FFF2-40B4-BE49-F238E27FC236}">
-                <a16:creationId xmlns:a16="http://schemas.microsoft.com/office/drawing/2014/main" id="{3F9060BF-CDAC-4632-9D05-EEEE52E90C0F}"/>
+                <a16:creationId xmlns:a16="http://schemas.microsoft.com/office/drawing/2014/main" id="{1020BB72-57E0-4416-9F3B-BC2CE67B54E3}"/>
               </a:ext>
             </a:extLst>
           </p:cNvPr>
@@ -9258,7 +9258,7 @@
           <p:cNvPr id="7" name="">
             <a:extLst xmlns:a="http://schemas.openxmlformats.org/drawingml/2006/main">
               <a:ext uri="{FF2B5EF4-FFF2-40B4-BE49-F238E27FC236}">
-                <a16:creationId xmlns:a16="http://schemas.microsoft.com/office/drawing/2014/main" id="{9A257C5D-A338-456A-9926-E25B1D5093A9}"/>
+                <a16:creationId xmlns:a16="http://schemas.microsoft.com/office/drawing/2014/main" id="{3C2EB221-6713-4F57-BB14-6C3A3BBBD9A1}"/>
               </a:ext>
             </a:extLst>
           </p:cNvPr>
@@ -9337,7 +9337,7 @@
           <p:cNvPr id="8" name="">
             <a:extLst xmlns:a="http://schemas.openxmlformats.org/drawingml/2006/main">
               <a:ext uri="{FF2B5EF4-FFF2-40B4-BE49-F238E27FC236}">
-                <a16:creationId xmlns:a16="http://schemas.microsoft.com/office/drawing/2014/main" id="{17EEAA08-F159-46C1-8FAF-43507E7BE19D}"/>
+                <a16:creationId xmlns:a16="http://schemas.microsoft.com/office/drawing/2014/main" id="{69BE90B6-C862-4844-94B5-0D31593585D5}"/>
               </a:ext>
             </a:extLst>
           </p:cNvPr>
@@ -9416,7 +9416,7 @@
           <p:cNvPr id="9" name="">
             <a:extLst xmlns:a="http://schemas.openxmlformats.org/drawingml/2006/main">
               <a:ext uri="{FF2B5EF4-FFF2-40B4-BE49-F238E27FC236}">
-                <a16:creationId xmlns:a16="http://schemas.microsoft.com/office/drawing/2014/main" id="{D76512EE-523C-4E53-B4FB-942929CDC820}"/>
+                <a16:creationId xmlns:a16="http://schemas.microsoft.com/office/drawing/2014/main" id="{C100EB79-C245-4E40-91DB-E05CDCB6FBA2}"/>
               </a:ext>
             </a:extLst>
           </p:cNvPr>
@@ -9495,7 +9495,7 @@
           <p:cNvPr id="10" name="">
             <a:extLst xmlns:a="http://schemas.openxmlformats.org/drawingml/2006/main">
               <a:ext uri="{FF2B5EF4-FFF2-40B4-BE49-F238E27FC236}">
-                <a16:creationId xmlns:a16="http://schemas.microsoft.com/office/drawing/2014/main" id="{359D8DC5-F98A-455E-AC80-DA4EB3848313}"/>
+                <a16:creationId xmlns:a16="http://schemas.microsoft.com/office/drawing/2014/main" id="{811C96DA-4383-4F55-A44C-C87892BFF8D7}"/>
               </a:ext>
             </a:extLst>
           </p:cNvPr>
@@ -9574,7 +9574,7 @@
           <p:cNvPr id="11" name="">
             <a:extLst xmlns:a="http://schemas.openxmlformats.org/drawingml/2006/main">
               <a:ext uri="{FF2B5EF4-FFF2-40B4-BE49-F238E27FC236}">
-                <a16:creationId xmlns:a16="http://schemas.microsoft.com/office/drawing/2014/main" id="{8DEE1E57-8E16-47C0-BBC3-1928A7BF9A97}"/>
+                <a16:creationId xmlns:a16="http://schemas.microsoft.com/office/drawing/2014/main" id="{43BA9937-433E-4C22-9D29-017F6C80887F}"/>
               </a:ext>
             </a:extLst>
           </p:cNvPr>
@@ -9653,7 +9653,7 @@
           <p:cNvPr id="12" name="">
             <a:extLst xmlns:a="http://schemas.openxmlformats.org/drawingml/2006/main">
               <a:ext uri="{FF2B5EF4-FFF2-40B4-BE49-F238E27FC236}">
-                <a16:creationId xmlns:a16="http://schemas.microsoft.com/office/drawing/2014/main" id="{16E7DED7-18F5-4CB4-AC2C-A873247C4B1C}"/>
+                <a16:creationId xmlns:a16="http://schemas.microsoft.com/office/drawing/2014/main" id="{19CE2395-EADE-4D24-BFF9-9E2225449E55}"/>
               </a:ext>
             </a:extLst>
           </p:cNvPr>
@@ -9732,7 +9732,7 @@
           <p:cNvPr id="13" name="">
             <a:extLst xmlns:a="http://schemas.openxmlformats.org/drawingml/2006/main">
               <a:ext uri="{FF2B5EF4-FFF2-40B4-BE49-F238E27FC236}">
-                <a16:creationId xmlns:a16="http://schemas.microsoft.com/office/drawing/2014/main" id="{7B1ECB06-5F54-45C0-98BB-513B5A90B0EE}"/>
+                <a16:creationId xmlns:a16="http://schemas.microsoft.com/office/drawing/2014/main" id="{CF1985F6-ECC5-47B8-B785-B024AF54D93C}"/>
               </a:ext>
             </a:extLst>
           </p:cNvPr>
@@ -9811,7 +9811,7 @@
           <p:cNvPr id="14" name="">
             <a:extLst xmlns:a="http://schemas.openxmlformats.org/drawingml/2006/main">
               <a:ext uri="{FF2B5EF4-FFF2-40B4-BE49-F238E27FC236}">
-                <a16:creationId xmlns:a16="http://schemas.microsoft.com/office/drawing/2014/main" id="{FFCE9159-EC64-42A4-A34F-7F6A9BB22963}"/>
+                <a16:creationId xmlns:a16="http://schemas.microsoft.com/office/drawing/2014/main" id="{FC1D602D-E531-4D14-9990-E380778B85BD}"/>
               </a:ext>
             </a:extLst>
           </p:cNvPr>
@@ -9890,7 +9890,7 @@
           <p:cNvPr id="15" name="">
             <a:extLst xmlns:a="http://schemas.openxmlformats.org/drawingml/2006/main">
               <a:ext uri="{FF2B5EF4-FFF2-40B4-BE49-F238E27FC236}">
-                <a16:creationId xmlns:a16="http://schemas.microsoft.com/office/drawing/2014/main" id="{1F9F336E-2D81-49CE-9BD5-C0FE3399CA03}"/>
+                <a16:creationId xmlns:a16="http://schemas.microsoft.com/office/drawing/2014/main" id="{C7DF65D6-0FA5-430E-80EA-CFBB0A44EB5D}"/>
               </a:ext>
             </a:extLst>
           </p:cNvPr>
@@ -9990,7 +9990,7 @@
           <p:cNvPr id="16" name="">
             <a:extLst xmlns:a="http://schemas.openxmlformats.org/drawingml/2006/main">
               <a:ext uri="{FF2B5EF4-FFF2-40B4-BE49-F238E27FC236}">
-                <a16:creationId xmlns:a16="http://schemas.microsoft.com/office/drawing/2014/main" id="{EAA35EDF-CE82-419E-8B5B-C6F5A165CAD9}"/>
+                <a16:creationId xmlns:a16="http://schemas.microsoft.com/office/drawing/2014/main" id="{0F16CFE7-F822-4464-8F5C-04A51E118F48}"/>
               </a:ext>
             </a:extLst>
           </p:cNvPr>
@@ -10067,7 +10067,7 @@
     </p:spTree>
     <p:extLst>
       <p:ext uri="{BB962C8B-B14F-4D97-AF65-F5344CB8AC3E}">
-        <p14:creationId xmlns:p14="http://schemas.microsoft.com/office/powerpoint/2010/main" val="207331150"/>
+        <p14:creationId xmlns:p14="http://schemas.microsoft.com/office/powerpoint/2010/main" val="453976686"/>
       </p:ext>
     </p:extLst>
   </p:cSld>
@@ -10098,7 +10098,7 @@
           <p:cNvPr id="5" name="">
             <a:extLst xmlns:a="http://schemas.openxmlformats.org/drawingml/2006/main">
               <a:ext uri="{FF2B5EF4-FFF2-40B4-BE49-F238E27FC236}">
-                <a16:creationId xmlns:a16="http://schemas.microsoft.com/office/drawing/2014/main" id="{F1B0EE18-30E0-4702-82AD-009E21508C58}"/>
+                <a16:creationId xmlns:a16="http://schemas.microsoft.com/office/drawing/2014/main" id="{897C61E5-295E-4A32-91B3-66653E90BB8C}"/>
               </a:ext>
             </a:extLst>
           </p:cNvPr>
@@ -10128,7 +10128,7 @@
           <p:cNvPr id="2" name="">
             <a:extLst xmlns:a="http://schemas.openxmlformats.org/drawingml/2006/main">
               <a:ext uri="{FF2B5EF4-FFF2-40B4-BE49-F238E27FC236}">
-                <a16:creationId xmlns:a16="http://schemas.microsoft.com/office/drawing/2014/main" id="{5C550E6C-DC63-4FED-8AEB-4DF6BADDE212}"/>
+                <a16:creationId xmlns:a16="http://schemas.microsoft.com/office/drawing/2014/main" id="{F65438F6-FE09-4799-8CB6-A5BF2FEEF97E}"/>
               </a:ext>
             </a:extLst>
           </p:cNvPr>
@@ -10207,7 +10207,7 @@
           <p:cNvPr id="3" name="Chart">
             <a:extLst xmlns:a="http://schemas.openxmlformats.org/drawingml/2006/main">
               <a:ext uri="{FF2B5EF4-FFF2-40B4-BE49-F238E27FC236}">
-                <a16:creationId xmlns:a16="http://schemas.microsoft.com/office/drawing/2014/main" id="{1FE49781-2382-4733-A970-462CD3D90372}"/>
+                <a16:creationId xmlns:a16="http://schemas.microsoft.com/office/drawing/2014/main" id="{24D4B8AA-EF26-48E5-A3A2-CAF92A9C970D}"/>
               </a:ext>
             </a:extLst>
           </p:cNvPr>
@@ -10220,7 +10220,7 @@
         </p:xfrm>
         <a:graphic xmlns:a="http://schemas.openxmlformats.org/drawingml/2006/main">
           <a:graphicData uri="http://schemas.openxmlformats.org/drawingml/2006/chart">
-            <c:chart xmlns:r="http://schemas.openxmlformats.org/officeDocument/2006/relationships" xmlns:c="http://schemas.openxmlformats.org/drawingml/2006/chart" r:id="R87e732572765481a"/>
+            <c:chart xmlns:r="http://schemas.openxmlformats.org/officeDocument/2006/relationships" xmlns:c="http://schemas.openxmlformats.org/drawingml/2006/chart" r:id="Re947daaf4cdc4d2a"/>
           </a:graphicData>
         </a:graphic>
       </p:graphicFrame>
@@ -10229,7 +10229,7 @@
           <p:cNvPr id="4" name="">
             <a:extLst xmlns:a="http://schemas.openxmlformats.org/drawingml/2006/main">
               <a:ext uri="{FF2B5EF4-FFF2-40B4-BE49-F238E27FC236}">
-                <a16:creationId xmlns:a16="http://schemas.microsoft.com/office/drawing/2014/main" id="{85F0A859-9EB6-4DA7-984C-61A4796079F0}"/>
+                <a16:creationId xmlns:a16="http://schemas.microsoft.com/office/drawing/2014/main" id="{0313F221-D8F1-4AF0-A490-E5BAAE6D74C3}"/>
               </a:ext>
             </a:extLst>
           </p:cNvPr>
@@ -10306,7 +10306,7 @@
     </p:spTree>
     <p:extLst>
       <p:ext uri="{BB962C8B-B14F-4D97-AF65-F5344CB8AC3E}">
-        <p14:creationId xmlns:p14="http://schemas.microsoft.com/office/powerpoint/2010/main" val="1912482621"/>
+        <p14:creationId xmlns:p14="http://schemas.microsoft.com/office/powerpoint/2010/main" val="75717540"/>
       </p:ext>
     </p:extLst>
   </p:cSld>
@@ -10337,7 +10337,7 @@
           <p:cNvPr id="5" name="">
             <a:extLst xmlns:a="http://schemas.openxmlformats.org/drawingml/2006/main">
               <a:ext uri="{FF2B5EF4-FFF2-40B4-BE49-F238E27FC236}">
-                <a16:creationId xmlns:a16="http://schemas.microsoft.com/office/drawing/2014/main" id="{5AE92364-77B6-4BA9-948D-BD3B8153C64C}"/>
+                <a16:creationId xmlns:a16="http://schemas.microsoft.com/office/drawing/2014/main" id="{F05A6EFE-4148-4D89-8BE6-EFDC5B3C95F1}"/>
               </a:ext>
             </a:extLst>
           </p:cNvPr>
@@ -10367,7 +10367,7 @@
           <p:cNvPr id="2" name="">
             <a:extLst xmlns:a="http://schemas.openxmlformats.org/drawingml/2006/main">
               <a:ext uri="{FF2B5EF4-FFF2-40B4-BE49-F238E27FC236}">
-                <a16:creationId xmlns:a16="http://schemas.microsoft.com/office/drawing/2014/main" id="{13D5C2E9-A277-4D94-BCE3-2A47C7617C68}"/>
+                <a16:creationId xmlns:a16="http://schemas.microsoft.com/office/drawing/2014/main" id="{59A9EFCA-2514-446D-9704-1A322B02AE6C}"/>
               </a:ext>
             </a:extLst>
           </p:cNvPr>
@@ -10446,7 +10446,7 @@
           <p:cNvPr id="3" name="">
             <a:extLst xmlns:a="http://schemas.openxmlformats.org/drawingml/2006/main">
               <a:ext uri="{FF2B5EF4-FFF2-40B4-BE49-F238E27FC236}">
-                <a16:creationId xmlns:a16="http://schemas.microsoft.com/office/drawing/2014/main" id="{96E6B567-B9E1-4DE6-BED1-2D8178AB7947}"/>
+                <a16:creationId xmlns:a16="http://schemas.microsoft.com/office/drawing/2014/main" id="{C0EE52A9-5E46-4932-A712-2D22280C4404}"/>
               </a:ext>
             </a:extLst>
           </p:cNvPr>
@@ -11656,7 +11656,7 @@
           <p:cNvPr id="4" name="">
             <a:extLst xmlns:a="http://schemas.openxmlformats.org/drawingml/2006/main">
               <a:ext uri="{FF2B5EF4-FFF2-40B4-BE49-F238E27FC236}">
-                <a16:creationId xmlns:a16="http://schemas.microsoft.com/office/drawing/2014/main" id="{5F87785E-B6E0-46F7-9AF8-600FEE987E8A}"/>
+                <a16:creationId xmlns:a16="http://schemas.microsoft.com/office/drawing/2014/main" id="{CECEF8E0-9052-4FB3-A8BA-B2AF9DE04C78}"/>
               </a:ext>
             </a:extLst>
           </p:cNvPr>
@@ -11733,7 +11733,7 @@
     </p:spTree>
     <p:extLst>
       <p:ext uri="{BB962C8B-B14F-4D97-AF65-F5344CB8AC3E}">
-        <p14:creationId xmlns:p14="http://schemas.microsoft.com/office/powerpoint/2010/main" val="1656784063"/>
+        <p14:creationId xmlns:p14="http://schemas.microsoft.com/office/powerpoint/2010/main" val="1306143220"/>
       </p:ext>
     </p:extLst>
   </p:cSld>
@@ -11764,7 +11764,7 @@
           <p:cNvPr id="4" name="">
             <a:extLst xmlns:a="http://schemas.openxmlformats.org/drawingml/2006/main">
               <a:ext uri="{FF2B5EF4-FFF2-40B4-BE49-F238E27FC236}">
-                <a16:creationId xmlns:a16="http://schemas.microsoft.com/office/drawing/2014/main" id="{5D322D4F-01D5-4D1A-B6E6-E353BF078816}"/>
+                <a16:creationId xmlns:a16="http://schemas.microsoft.com/office/drawing/2014/main" id="{2C2E8D39-9A0E-4409-BA42-5F60F8853047}"/>
               </a:ext>
             </a:extLst>
           </p:cNvPr>
@@ -11794,7 +11794,7 @@
           <p:cNvPr id="2" name="">
             <a:extLst xmlns:a="http://schemas.openxmlformats.org/drawingml/2006/main">
               <a:ext uri="{FF2B5EF4-FFF2-40B4-BE49-F238E27FC236}">
-                <a16:creationId xmlns:a16="http://schemas.microsoft.com/office/drawing/2014/main" id="{ADEF1AD3-734B-4919-A2BF-3F16ED7B7DDF}"/>
+                <a16:creationId xmlns:a16="http://schemas.microsoft.com/office/drawing/2014/main" id="{3B3E9A77-EE78-4C2A-AACB-9EC0937D31ED}"/>
               </a:ext>
             </a:extLst>
           </p:cNvPr>
@@ -11873,7 +11873,7 @@
           <p:cNvPr id="3" name="">
             <a:extLst xmlns:a="http://schemas.openxmlformats.org/drawingml/2006/main">
               <a:ext uri="{FF2B5EF4-FFF2-40B4-BE49-F238E27FC236}">
-                <a16:creationId xmlns:a16="http://schemas.microsoft.com/office/drawing/2014/main" id="{77BC512C-D2DE-44C6-891C-6F6B6C874ED5}"/>
+                <a16:creationId xmlns:a16="http://schemas.microsoft.com/office/drawing/2014/main" id="{EEBB6EDC-CB39-408B-A533-49CC6A374F6D}"/>
               </a:ext>
             </a:extLst>
           </p:cNvPr>
@@ -11883,7 +11883,7 @@
           <p:nvPr/>
         </p:nvPicPr>
         <p:blipFill>
-          <a:blip xmlns:r="http://schemas.openxmlformats.org/officeDocument/2006/relationships" xmlns:a="http://schemas.openxmlformats.org/drawingml/2006/main" r:embed="R7f4b2b2412db438a"/>
+          <a:blip xmlns:r="http://schemas.openxmlformats.org/officeDocument/2006/relationships" xmlns:a="http://schemas.openxmlformats.org/drawingml/2006/main" r:embed="Rae5f0049f2c349f9"/>
           <a:stretch xmlns:a="http://schemas.openxmlformats.org/drawingml/2006/main"/>
         </p:blipFill>
         <p:spPr>
@@ -11899,7 +11899,7 @@
     </p:spTree>
     <p:extLst>
       <p:ext uri="{BB962C8B-B14F-4D97-AF65-F5344CB8AC3E}">
-        <p14:creationId xmlns:p14="http://schemas.microsoft.com/office/powerpoint/2010/main" val="1050523994"/>
+        <p14:creationId xmlns:p14="http://schemas.microsoft.com/office/powerpoint/2010/main" val="585413591"/>
       </p:ext>
     </p:extLst>
   </p:cSld>
@@ -11930,7 +11930,7 @@
           <p:cNvPr id="5" name="">
             <a:extLst xmlns:a="http://schemas.openxmlformats.org/drawingml/2006/main">
               <a:ext uri="{FF2B5EF4-FFF2-40B4-BE49-F238E27FC236}">
-                <a16:creationId xmlns:a16="http://schemas.microsoft.com/office/drawing/2014/main" id="{6D3E903D-7C6B-487B-B26E-3B19FB9060B7}"/>
+                <a16:creationId xmlns:a16="http://schemas.microsoft.com/office/drawing/2014/main" id="{E68949A5-3152-4325-856F-DD5474F94003}"/>
               </a:ext>
             </a:extLst>
           </p:cNvPr>
@@ -11960,7 +11960,7 @@
           <p:cNvPr id="2" name="">
             <a:extLst xmlns:a="http://schemas.openxmlformats.org/drawingml/2006/main">
               <a:ext uri="{FF2B5EF4-FFF2-40B4-BE49-F238E27FC236}">
-                <a16:creationId xmlns:a16="http://schemas.microsoft.com/office/drawing/2014/main" id="{2BFE39B0-FCBF-423E-8E5A-5C391E7D3310}"/>
+                <a16:creationId xmlns:a16="http://schemas.microsoft.com/office/drawing/2014/main" id="{F1A19746-2C17-40B4-9A6A-473E141747FE}"/>
               </a:ext>
             </a:extLst>
           </p:cNvPr>
@@ -12039,7 +12039,7 @@
           <p:cNvPr id="3" name="">
             <a:extLst xmlns:a="http://schemas.openxmlformats.org/drawingml/2006/main">
               <a:ext uri="{FF2B5EF4-FFF2-40B4-BE49-F238E27FC236}">
-                <a16:creationId xmlns:a16="http://schemas.microsoft.com/office/drawing/2014/main" id="{3CF66A5C-3107-4F79-81BF-A87B3571E5E2}"/>
+                <a16:creationId xmlns:a16="http://schemas.microsoft.com/office/drawing/2014/main" id="{B4B1C63D-ECC2-4771-B621-576C174FEE56}"/>
               </a:ext>
             </a:extLst>
           </p:cNvPr>
@@ -13312,7 +13312,7 @@
           <p:cNvPr id="4" name="">
             <a:extLst xmlns:a="http://schemas.openxmlformats.org/drawingml/2006/main">
               <a:ext uri="{FF2B5EF4-FFF2-40B4-BE49-F238E27FC236}">
-                <a16:creationId xmlns:a16="http://schemas.microsoft.com/office/drawing/2014/main" id="{65C00643-3444-41D2-A911-2803C86921A0}"/>
+                <a16:creationId xmlns:a16="http://schemas.microsoft.com/office/drawing/2014/main" id="{5A141F07-9121-45DF-88FB-97E10B317901}"/>
               </a:ext>
             </a:extLst>
           </p:cNvPr>
@@ -13389,7 +13389,7 @@
     </p:spTree>
     <p:extLst>
       <p:ext uri="{BB962C8B-B14F-4D97-AF65-F5344CB8AC3E}">
-        <p14:creationId xmlns:p14="http://schemas.microsoft.com/office/powerpoint/2010/main" val="682142927"/>
+        <p14:creationId xmlns:p14="http://schemas.microsoft.com/office/powerpoint/2010/main" val="466182523"/>
       </p:ext>
     </p:extLst>
   </p:cSld>

</xml_diff>